<commit_message>
Adapter met vaste kabel als nieuwe standaard op slide 6
De kwaliteitskaart vraagt nu dat elk apparaat voortaan standaard een lader krijgt waarvan de kabel vastzit aan de adapter, zodat de klant altijd de juiste adapter voor dat apparaat gebruikt. Om ruimte te maken zijn de twee batterijpunten samengevoegd tot één regel over looptijd en levensduur.

Co-Authored-By: Claude Opus 5.5 <noreply@anthropic.com>
Claude-Session: https://claude.ai/code/session_01YKcRMpiL4Gas7FwYTKCw5d
</commit_message>
<xml_diff>
--- a/presentaties/fabrieksbezoek-china-2026/uitvoer/Wellshave_Factory_Visit_FANKE.pptx
+++ b/presentaties/fabrieksbezoek-china-2026/uitvoer/Wellshave_Factory_Visit_FANKE.pptx
@@ -114,25 +114,25 @@
   <p:extLst>
     <p:ext uri="{521415D9-36F7-43E2-AB2F-B90AF26B5E84}">
       <p14:sectionLst xmlns:p14="http://schemas.microsoft.com/office/powerpoint/2010/main">
-        <p14:section name="Introduction" id="{5725b1ad-2257-b183-2282-07540cd7515d}">
+        <p14:section name="Introduction" id="{6cab8bc2-5ac3-6738-9161-cab698a43633}">
           <p14:sldIdLst>
             <p14:sldId id="256"/>
           </p14:sldIdLst>
         </p14:section>
-        <p14:section name="About Wellshave" id="{2f02d7b9-d076-cb4b-f50d-d0aca34c466a}">
+        <p14:section name="About Wellshave" id="{58eb8cab-391a-bcbc-fdd3-9becfb289b83}">
           <p14:sldIdLst>
             <p14:sldId id="257"/>
             <p14:sldId id="258"/>
           </p14:sldIdLst>
         </p14:section>
-        <p14:section name="The visit" id="{e061b23a-bc2e-4903-bc6e-2e1c8c5468e3}">
+        <p14:section name="The visit" id="{420365e4-7c7d-7d71-53cb-ebfceb4af7bf}">
           <p14:sldIdLst>
             <p14:sldId id="259"/>
             <p14:sldId id="260"/>
             <p14:sldId id="261"/>
           </p14:sldIdLst>
         </p14:section>
-        <p14:section name="Our products with you" id="{eebd3555-7cfe-024a-394e-9b6cfc2c92b9}">
+        <p14:section name="Our products with you" id="{83729c62-228b-a7f4-4102-b4ac1bef250b}">
           <p14:sldIdLst>
             <p14:sldId id="262"/>
             <p14:sldId id="263"/>
@@ -982,7 +982,7 @@
           <a:p>
             <a:r>
               <a:rPr lang="en-US" dirty="0"/>
-              <a:t/>
+              <a:t>Fixed-cable adapter: from now on every device ships with a charger whose cable is fixed to the adapter, so customers always charge with the right adapter for that device. Wrong adapters damage batteries and lead to returns.</a:t>
             </a:r>
             <a:endParaRPr lang="en-US" dirty="0"/>
           </a:p>
@@ -6800,11 +6800,11 @@
         <p:spPr>
           <a:xfrm>
             <a:off x="548640" y="1755648"/>
-            <a:ext cx="3515258" cy="3401568"/>
+            <a:ext cx="3515258" cy="3639312"/>
           </a:xfrm>
           <a:prstGeom prst="roundRect">
             <a:avLst>
-              <a:gd name="adj" fmla="val 4301"/>
+              <a:gd name="adj" fmla="val 4162"/>
             </a:avLst>
           </a:prstGeom>
           <a:solidFill>
@@ -6984,7 +6984,7 @@
         <p:spPr>
           <a:xfrm>
             <a:off x="822960" y="3474720"/>
-            <a:ext cx="3058058" cy="1627632"/>
+            <a:ext cx="3058058" cy="1828800"/>
           </a:xfrm>
           <a:prstGeom prst="rect">
             <a:avLst/>
@@ -6998,7 +6998,7 @@
           <a:p>
             <a:pPr indent="0" marL="0">
               <a:spcAft>
-                <a:spcPts val="1000"/>
+                <a:spcPts val="800"/>
               </a:spcAft>
               <a:buNone/>
             </a:pPr>
@@ -7008,12 +7008,12 @@
                   <a:schemeClr val="bg1"/>
                 </a:solidFill>
               </a:rPr>
-              <a:t>Longer battery life per charge</a:t>
+              <a:t>Longer battery life and lifespan</a:t>
             </a:r>
             <a:br/>
             <a:pPr indent="0" marL="0">
               <a:spcAft>
-                <a:spcPts val="1000"/>
+                <a:spcPts val="800"/>
               </a:spcAft>
               <a:buNone/>
             </a:pPr>
@@ -7026,14 +7026,14 @@
                 <a:ea typeface="Microsoft YaHei" pitchFamily="34" charset="-122"/>
                 <a:cs typeface="Microsoft YaHei" pitchFamily="34" charset="-120"/>
               </a:rPr>
-              <a:t>单次充电续航更长</a:t>
+              <a:t>续航更长，电池寿命更长</a:t>
             </a:r>
             <a:endParaRPr lang="en-US" sz="1400" dirty="0"/>
           </a:p>
           <a:p>
             <a:pPr indent="0" marL="0">
               <a:spcAft>
-                <a:spcPts val="1000"/>
+                <a:spcPts val="800"/>
               </a:spcAft>
               <a:buNone/>
             </a:pPr>
@@ -7043,12 +7043,12 @@
                   <a:schemeClr val="bg1"/>
                 </a:solidFill>
               </a:rPr>
-              <a:t>Longer battery lifespan</a:t>
+              <a:t>Fixed-cable adapter as standard</a:t>
             </a:r>
             <a:br/>
             <a:pPr indent="0" marL="0">
               <a:spcAft>
-                <a:spcPts val="1000"/>
+                <a:spcPts val="800"/>
               </a:spcAft>
               <a:buNone/>
             </a:pPr>
@@ -7061,41 +7061,74 @@
                 <a:ea typeface="Microsoft YaHei" pitchFamily="34" charset="-122"/>
                 <a:cs typeface="Microsoft YaHei" pitchFamily="34" charset="-120"/>
               </a:rPr>
-              <a:t>电池使用寿命更长</a:t>
-            </a:r>
-            <a:endParaRPr lang="en-US" sz="1400" dirty="0"/>
-          </a:p>
-          <a:p>
-            <a:pPr indent="0" marL="0">
-              <a:spcAft>
-                <a:spcPts val="1000"/>
-              </a:spcAft>
-              <a:buNone/>
-            </a:pPr>
-            <a:r>
-              <a:rPr lang="en-US" sz="1400" dirty="0">
-                <a:solidFill>
-                  <a:schemeClr val="bg1"/>
-                </a:solidFill>
-              </a:rPr>
-              <a:t>Fewer defects and returns</a:t>
+              <a:t>今后标配线缆固定的一体式适配器</a:t>
             </a:r>
             <a:br/>
             <a:pPr indent="0" marL="0">
               <a:spcAft>
-                <a:spcPts val="1000"/>
-              </a:spcAft>
-              <a:buNone/>
-            </a:pPr>
-            <a:r>
-              <a:rPr lang="en-US" sz="1300" dirty="0">
-                <a:solidFill>
-                  <a:schemeClr val="accent3"/>
+                <a:spcPts val="800"/>
+              </a:spcAft>
+              <a:buNone/>
+            </a:pPr>
+            <a:r>
+              <a:rPr lang="en-US" sz="1100" dirty="0">
+                <a:solidFill>
+                  <a:schemeClr val="accent2"/>
+                </a:solidFill>
+              </a:rPr>
+              <a:t>So the right adapter is always used</a:t>
+            </a:r>
+            <a:br/>
+            <a:pPr indent="0" marL="0">
+              <a:spcAft>
+                <a:spcPts val="800"/>
+              </a:spcAft>
+              <a:buNone/>
+            </a:pPr>
+            <a:r>
+              <a:rPr lang="en-US" sz="1100" dirty="0">
+                <a:solidFill>
+                  <a:schemeClr val="accent2"/>
                 </a:solidFill>
                 <a:latin typeface="Microsoft YaHei" pitchFamily="34" charset="0"/>
                 <a:ea typeface="Microsoft YaHei" pitchFamily="34" charset="-122"/>
                 <a:cs typeface="Microsoft YaHei" pitchFamily="34" charset="-120"/>
               </a:rPr>
+              <a:t>确保客户始终使用与设备匹配的适配器</a:t>
+            </a:r>
+            <a:endParaRPr lang="en-US" sz="1400" dirty="0"/>
+          </a:p>
+          <a:p>
+            <a:pPr indent="0" marL="0">
+              <a:spcAft>
+                <a:spcPts val="800"/>
+              </a:spcAft>
+              <a:buNone/>
+            </a:pPr>
+            <a:r>
+              <a:rPr lang="en-US" sz="1400" dirty="0">
+                <a:solidFill>
+                  <a:schemeClr val="bg1"/>
+                </a:solidFill>
+              </a:rPr>
+              <a:t>Fewer defects and returns</a:t>
+            </a:r>
+            <a:br/>
+            <a:pPr indent="0" marL="0">
+              <a:spcAft>
+                <a:spcPts val="800"/>
+              </a:spcAft>
+              <a:buNone/>
+            </a:pPr>
+            <a:r>
+              <a:rPr lang="en-US" sz="1300" dirty="0">
+                <a:solidFill>
+                  <a:schemeClr val="accent3"/>
+                </a:solidFill>
+                <a:latin typeface="Microsoft YaHei" pitchFamily="34" charset="0"/>
+                <a:ea typeface="Microsoft YaHei" pitchFamily="34" charset="-122"/>
+                <a:cs typeface="Microsoft YaHei" pitchFamily="34" charset="-120"/>
+              </a:rPr>
               <a:t>减少故障和退货</a:t>
             </a:r>
             <a:endParaRPr lang="en-US" sz="1400" dirty="0"/>
@@ -7111,11 +7144,11 @@
         <p:spPr>
           <a:xfrm>
             <a:off x="4338218" y="1755648"/>
-            <a:ext cx="3515258" cy="3401568"/>
+            <a:ext cx="3515258" cy="3639312"/>
           </a:xfrm>
           <a:prstGeom prst="roundRect">
             <a:avLst>
-              <a:gd name="adj" fmla="val 4301"/>
+              <a:gd name="adj" fmla="val 4162"/>
             </a:avLst>
           </a:prstGeom>
           <a:solidFill>
@@ -7295,7 +7328,7 @@
         <p:spPr>
           <a:xfrm>
             <a:off x="4612538" y="3474720"/>
-            <a:ext cx="3058058" cy="1627632"/>
+            <a:ext cx="3058058" cy="1828800"/>
           </a:xfrm>
           <a:prstGeom prst="rect">
             <a:avLst/>
@@ -7309,7 +7342,7 @@
           <a:p>
             <a:pPr indent="0" marL="0">
               <a:spcAft>
-                <a:spcPts val="1000"/>
+                <a:spcPts val="800"/>
               </a:spcAft>
               <a:buNone/>
             </a:pPr>
@@ -7324,7 +7357,7 @@
             <a:br/>
             <a:pPr indent="0" marL="0">
               <a:spcAft>
-                <a:spcPts val="1000"/>
+                <a:spcPts val="800"/>
               </a:spcAft>
               <a:buNone/>
             </a:pPr>
@@ -7344,7 +7377,7 @@
           <a:p>
             <a:pPr indent="0" marL="0">
               <a:spcAft>
-                <a:spcPts val="1000"/>
+                <a:spcPts val="800"/>
               </a:spcAft>
               <a:buNone/>
             </a:pPr>
@@ -7359,7 +7392,7 @@
             <a:br/>
             <a:pPr indent="0" marL="0">
               <a:spcAft>
-                <a:spcPts val="1000"/>
+                <a:spcPts val="800"/>
               </a:spcAft>
               <a:buNone/>
             </a:pPr>
@@ -7379,7 +7412,7 @@
           <a:p>
             <a:pPr indent="0" marL="0">
               <a:spcAft>
-                <a:spcPts val="1000"/>
+                <a:spcPts val="800"/>
               </a:spcAft>
               <a:buNone/>
             </a:pPr>
@@ -7394,7 +7427,7 @@
             <a:br/>
             <a:pPr indent="0" marL="0">
               <a:spcAft>
-                <a:spcPts val="1000"/>
+                <a:spcPts val="800"/>
               </a:spcAft>
               <a:buNone/>
             </a:pPr>
@@ -7422,11 +7455,11 @@
         <p:spPr>
           <a:xfrm>
             <a:off x="8127797" y="1755648"/>
-            <a:ext cx="3515258" cy="3401568"/>
+            <a:ext cx="3515258" cy="3639312"/>
           </a:xfrm>
           <a:prstGeom prst="roundRect">
             <a:avLst>
-              <a:gd name="adj" fmla="val 4301"/>
+              <a:gd name="adj" fmla="val 4162"/>
             </a:avLst>
           </a:prstGeom>
           <a:solidFill>
@@ -7606,7 +7639,7 @@
         <p:spPr>
           <a:xfrm>
             <a:off x="8402117" y="3474720"/>
-            <a:ext cx="3058058" cy="1627632"/>
+            <a:ext cx="3058058" cy="1828800"/>
           </a:xfrm>
           <a:prstGeom prst="rect">
             <a:avLst/>
@@ -7620,7 +7653,7 @@
           <a:p>
             <a:pPr indent="0" marL="0">
               <a:spcAft>
-                <a:spcPts val="1000"/>
+                <a:spcPts val="800"/>
               </a:spcAft>
               <a:buNone/>
             </a:pPr>
@@ -7635,7 +7668,7 @@
             <a:br/>
             <a:pPr indent="0" marL="0">
               <a:spcAft>
-                <a:spcPts val="1000"/>
+                <a:spcPts val="800"/>
               </a:spcAft>
               <a:buNone/>
             </a:pPr>
@@ -7655,7 +7688,7 @@
           <a:p>
             <a:pPr indent="0" marL="0">
               <a:spcAft>
-                <a:spcPts val="1000"/>
+                <a:spcPts val="800"/>
               </a:spcAft>
               <a:buNone/>
             </a:pPr>
@@ -7670,7 +7703,7 @@
             <a:br/>
             <a:pPr indent="0" marL="0">
               <a:spcAft>
-                <a:spcPts val="1000"/>
+                <a:spcPts val="800"/>
               </a:spcAft>
               <a:buNone/>
             </a:pPr>
@@ -7690,7 +7723,7 @@
           <a:p>
             <a:pPr indent="0" marL="0">
               <a:spcAft>
-                <a:spcPts val="1000"/>
+                <a:spcPts val="800"/>
               </a:spcAft>
               <a:buNone/>
             </a:pPr>
@@ -7705,7 +7738,7 @@
             <a:br/>
             <a:pPr indent="0" marL="0">
               <a:spcAft>
-                <a:spcPts val="1000"/>
+                <a:spcPts val="800"/>
               </a:spcAft>
               <a:buNone/>
             </a:pPr>
@@ -7732,7 +7765,7 @@
         </p:nvSpPr>
         <p:spPr>
           <a:xfrm>
-            <a:off x="548640" y="5394960"/>
+            <a:off x="548640" y="5559552"/>
             <a:ext cx="11094415" cy="621792"/>
           </a:xfrm>
           <a:prstGeom prst="rect">

</xml_diff>